<commit_message>
feat: update /info pitch deck and PPTX with Google MedLM, CDSCO & PMBJP medical models
</commit_message>
<xml_diff>
--- a/GharCare_Pitch_Deck_AAYU_2026.pptx
+++ b/GharCare_Pitch_Deck_AAYU_2026.pptx
@@ -863,7 +863,7 @@
           <a:p>
             <a:r>
               <a:rPr lang="en-US" dirty="0"/>
-              <a:t>Traditional OCR fails on folded papers, doctor handwriting, and carbon copies. Gemini 2.5 Flash multimodal vision directly processes raw pixels in 1.2 seconds, achieving 94.6% accuracy without brittle OCR preprocessing pipelines.</a:t>
+              <a:t>General Western LLMs fail in Indian hospitals because they do not recognize Indian commercial drug brands like Metolar or Pan-D. We combine Google MedLM trained on biomedical literature with Gemini 2.5 multimodal vision and the CDSCO Indian formulary to achieve 94.6% entity accuracy in 1.2s.</a:t>
             </a:r>
             <a:endParaRPr lang="en-US" dirty="0"/>
           </a:p>
@@ -1127,7 +1127,7 @@
           <a:p>
             <a:r>
               <a:rPr lang="en-US" dirty="0"/>
-              <a:t>We leverage the full Google ecosystem: Gemini 2.5 for vision, Cloud TTS for regional audio, Google Calendar RFC 5545 for medication reminders, and Google Maps to locate verified 24/7 Jan Aushadhi generic pharmacies.</a:t>
+              <a:t>We leverage the entire Google ecosystem: Google MedLM on Vertex AI, Gemini 2.5 Flash for vision, Cloud TTS for regional audio, Google Calendar RFC 5545 for auto-syncing medication reminders, and Google Maps for 24/7 Jan Aushadhi pharmacies.</a:t>
             </a:r>
             <a:endParaRPr lang="en-US" dirty="0"/>
           </a:p>
@@ -1779,7 +1779,7 @@
               <a:buNone/>
             </a:pPr>
             <a:r>
-              <a:rPr lang="en-US" sz="1800" b="1" dirty="0">
+              <a:rPr lang="en-US" sz="1700" b="1" dirty="0">
                 <a:solidFill>
                   <a:srgbClr val="14B8A6"/>
                 </a:solidFill>
@@ -1787,9 +1787,9 @@
                 <a:ea typeface="Arial" pitchFamily="34" charset="-122"/>
                 <a:cs typeface="Arial" pitchFamily="34" charset="-120"/>
               </a:rPr>
-              <a:t>Next-Gen Hospital Discharge Handover Protocol &amp; Family Recovery System</a:t>
-            </a:r>
-            <a:endParaRPr lang="en-US" sz="1800" dirty="0"/>
+              <a:t>Specialized Healthcare AI (Google MedLM + Gemini 2.5 Flash) + CDSCO &amp; PMBJP Indian Clinical Engine</a:t>
+            </a:r>
+            <a:endParaRPr lang="en-US" sz="1700" dirty="0"/>
           </a:p>
         </p:txBody>
       </p:sp>
@@ -1826,7 +1826,7 @@
                 <a:ea typeface="Arial" pitchFamily="34" charset="-122"/>
                 <a:cs typeface="Arial" pitchFamily="34" charset="-120"/>
               </a:rPr>
-              <a:t>Powered by Google Gemini 2.5 Flash, Vertex AI MedLM, Cloud TTS Neural2 &amp; ABDM Clinical Rails</a:t>
+              <a:t>Domain-Specific Clinical Intelligence: Vertex AI MedLM, CDSCO Indian Formulary, PMBJP Jan Aushadhi &amp; ABDM Rails</a:t>
             </a:r>
             <a:endParaRPr lang="en-US" sz="1200" dirty="0"/>
           </a:p>
@@ -1890,7 +1890,7 @@
                 <a:ea typeface="Arial" pitchFamily="34" charset="-122"/>
                 <a:cs typeface="Arial" pitchFamily="34" charset="-120"/>
               </a:rPr>
-              <a:t>1.2s Multimodal Vision</a:t>
+              <a:t>Google MedLM + Gemini 2.5</a:t>
             </a:r>
             <a:endParaRPr lang="en-US" sz="1400" dirty="0"/>
           </a:p>
@@ -1929,7 +1929,7 @@
                 <a:ea typeface="Arial" pitchFamily="34" charset="-122"/>
                 <a:cs typeface="Arial" pitchFamily="34" charset="-120"/>
               </a:rPr>
-              <a:t>Gemini 2.5 Flash extracts crumpled notes, handwriting &amp; tables without OCR errors.</a:t>
+              <a:t>MedLM clinical reasoning + Gemini 2.5 Flash multimodal vision extracts doctor notes &amp; tables in 1.2s.</a:t>
             </a:r>
             <a:endParaRPr lang="en-US" sz="1100" dirty="0"/>
           </a:p>
@@ -1993,7 +1993,7 @@
                 <a:ea typeface="Arial" pitchFamily="34" charset="-122"/>
                 <a:cs typeface="Arial" pitchFamily="34" charset="-120"/>
               </a:rPr>
-              <a:t>Zero-Hallucination Firewall</a:t>
+              <a:t>CDSCO &amp; Safety Rail</a:t>
             </a:r>
             <a:endParaRPr lang="en-US" sz="1400" dirty="0"/>
           </a:p>
@@ -2032,7 +2032,7 @@
                 <a:ea typeface="Arial" pitchFamily="34" charset="-122"/>
                 <a:cs typeface="Arial" pitchFamily="34" charset="-120"/>
               </a:rPr>
-              <a:t>Deterministic code-level rules flag missing dosages, drug clashes &amp; enforce Senior Nurse sign-off.</a:t>
+              <a:t>Deterministic verification maps Indian brands (Metolar, Pan-D, Augmentin) &amp; enforces Senior Nurse lock.</a:t>
             </a:r>
             <a:endParaRPr lang="en-US" sz="1100" dirty="0"/>
           </a:p>
@@ -2096,7 +2096,7 @@
                 <a:ea typeface="Arial" pitchFamily="34" charset="-122"/>
                 <a:cs typeface="Arial" pitchFamily="34" charset="-120"/>
               </a:rPr>
-              <a:t>Multilingual Awaaz Parchi</a:t>
+              <a:t>PMBJP Savings &amp; Awaaz Parchi</a:t>
             </a:r>
             <a:endParaRPr lang="en-US" sz="1400" dirty="0"/>
           </a:p>
@@ -2135,7 +2135,7 @@
                 <a:ea typeface="Arial" pitchFamily="34" charset="-122"/>
                 <a:cs typeface="Arial" pitchFamily="34" charset="-120"/>
               </a:rPr>
-              <a:t>Spoken Hindi audio instructions, RFC 5545 Google Calendar sync &amp; 24/7 Jan Aushadhi maps.</a:t>
+              <a:t>Spoken Hindi audio handover, up to 85% Jan Aushadhi generic savings, and Google Calendar sync.</a:t>
             </a:r>
             <a:endParaRPr lang="en-US" sz="1100" dirty="0"/>
           </a:p>
@@ -5292,7 +5292,7 @@
                 <a:ea typeface="Arial" pitchFamily="34" charset="-122"/>
                 <a:cs typeface="Arial" pitchFamily="34" charset="-120"/>
               </a:rPr>
-              <a:t>TECHNOLOGY DEEP DIVE</a:t>
+              <a:t>SPECIALIZED CLINICAL AI</a:t>
             </a:r>
             <a:endParaRPr lang="en-US" sz="1000" dirty="0"/>
           </a:p>
@@ -5370,7 +5370,7 @@
                 <a:ea typeface="Arial" pitchFamily="34" charset="-122"/>
                 <a:cs typeface="Arial" pitchFamily="34" charset="-120"/>
               </a:rPr>
-              <a:t>Multimodal Clinical Fact Extraction</a:t>
+              <a:t>Specialized Medical AI &amp; Indian Clinical Engine</a:t>
             </a:r>
             <a:endParaRPr lang="en-US" sz="2200" dirty="0"/>
           </a:p>
@@ -5409,7 +5409,7 @@
                 <a:ea typeface="Arial" pitchFamily="34" charset="-122"/>
                 <a:cs typeface="Arial" pitchFamily="34" charset="-120"/>
               </a:rPr>
-              <a:t>Google Gemini 2.5 Flash: Cracking Complex Discharge Papers in 1.2 Seconds</a:t>
+              <a:t>Google MedLM (Vertex AI) + Gemini 2.5 Flash Vision + CDSCO &amp; PMBJP Registry</a:t>
             </a:r>
             <a:endParaRPr lang="en-US" sz="1200" dirty="0"/>
           </a:p>
@@ -5449,7 +5449,7 @@
         <p:spPr>
           <a:xfrm>
             <a:off x="731520" y="1920240"/>
-            <a:ext cx="5212080" cy="3108960"/>
+            <a:ext cx="3383280" cy="3291840"/>
           </a:xfrm>
           <a:prstGeom prst="roundRect">
             <a:avLst/>
@@ -5457,9 +5457,9 @@
           <a:solidFill>
             <a:srgbClr val="0F172A"/>
           </a:solidFill>
-          <a:ln w="12700">
+          <a:ln w="19050">
             <a:solidFill>
-              <a:srgbClr val="F43F5E"/>
+              <a:srgbClr val="C084FC"/>
             </a:solidFill>
             <a:prstDash val="solid"/>
           </a:ln>
@@ -5474,33 +5474,33 @@
         <p:spPr>
           <a:xfrm>
             <a:off x="1005840" y="2103120"/>
-            <a:ext cx="4663440" cy="365760"/>
-          </a:xfrm>
-          <a:prstGeom prst="rect">
-            <a:avLst/>
-          </a:prstGeom>
-          <a:noFill/>
-          <a:ln/>
-        </p:spPr>
-        <p:txBody>
-          <a:bodyPr wrap="square" rtlCol="0" anchor="ctr"/>
-          <a:lstStyle/>
-          <a:p>
-            <a:pPr indent="0" marL="0">
-              <a:buNone/>
-            </a:pPr>
-            <a:r>
-              <a:rPr lang="en-US" sz="1200" b="1" dirty="0">
-                <a:solidFill>
-                  <a:srgbClr val="F43F5E"/>
-                </a:solidFill>
-                <a:latin typeface="Arial" pitchFamily="34" charset="0"/>
-                <a:ea typeface="Arial" pitchFamily="34" charset="-122"/>
-                <a:cs typeface="Arial" pitchFamily="34" charset="-120"/>
-              </a:rPr>
-              <a:t>⚠️ WHY TRADITIONAL OCR PIPELINES FAIL</a:t>
-            </a:r>
-            <a:endParaRPr lang="en-US" sz="1200" dirty="0"/>
+            <a:ext cx="2834640" cy="228600"/>
+          </a:xfrm>
+          <a:prstGeom prst="rect">
+            <a:avLst/>
+          </a:prstGeom>
+          <a:noFill/>
+          <a:ln/>
+        </p:spPr>
+        <p:txBody>
+          <a:bodyPr wrap="square" rtlCol="0" anchor="ctr"/>
+          <a:lstStyle/>
+          <a:p>
+            <a:pPr indent="0" marL="0">
+              <a:buNone/>
+            </a:pPr>
+            <a:r>
+              <a:rPr lang="en-US" sz="850" b="1" dirty="0">
+                <a:solidFill>
+                  <a:srgbClr val="C084FC"/>
+                </a:solidFill>
+                <a:latin typeface="Arial" pitchFamily="34" charset="0"/>
+                <a:ea typeface="Arial" pitchFamily="34" charset="-122"/>
+                <a:cs typeface="Arial" pitchFamily="34" charset="-120"/>
+              </a:rPr>
+              <a:t>VERTEX AI HEALTHCARE</a:t>
+            </a:r>
+            <a:endParaRPr lang="en-US" sz="850" dirty="0"/>
           </a:p>
         </p:txBody>
       </p:sp>
@@ -5512,24 +5512,63 @@
         </p:nvSpPr>
         <p:spPr>
           <a:xfrm>
-            <a:off x="1005840" y="2560320"/>
-            <a:ext cx="4663440" cy="2286000"/>
-          </a:xfrm>
-          <a:prstGeom prst="rect">
-            <a:avLst/>
-          </a:prstGeom>
-          <a:noFill/>
-          <a:ln/>
-        </p:spPr>
-        <p:txBody>
-          <a:bodyPr wrap="square" rtlCol="0" anchor="ctr"/>
-          <a:lstStyle/>
-          <a:p>
-            <a:pPr indent="0" marL="0">
-              <a:buNone/>
-            </a:pPr>
-            <a:r>
-              <a:rPr lang="en-US" sz="1050" dirty="0">
+            <a:off x="1005840" y="2377440"/>
+            <a:ext cx="2834640" cy="411480"/>
+          </a:xfrm>
+          <a:prstGeom prst="rect">
+            <a:avLst/>
+          </a:prstGeom>
+          <a:noFill/>
+          <a:ln/>
+        </p:spPr>
+        <p:txBody>
+          <a:bodyPr wrap="square" rtlCol="0" anchor="ctr"/>
+          <a:lstStyle/>
+          <a:p>
+            <a:pPr indent="0" marL="0">
+              <a:buNone/>
+            </a:pPr>
+            <a:r>
+              <a:rPr lang="en-US" sz="1300" b="1" dirty="0">
+                <a:solidFill>
+                  <a:srgbClr val="FFFFFF"/>
+                </a:solidFill>
+                <a:latin typeface="Arial" pitchFamily="34" charset="0"/>
+                <a:ea typeface="Arial" pitchFamily="34" charset="-122"/>
+                <a:cs typeface="Arial" pitchFamily="34" charset="-120"/>
+              </a:rPr>
+              <a:t>Google MedLM Foundation Model</a:t>
+            </a:r>
+            <a:endParaRPr lang="en-US" sz="1300" dirty="0"/>
+          </a:p>
+        </p:txBody>
+      </p:sp>
+      <p:sp>
+        <p:nvSpPr>
+          <p:cNvPr id="10" name="Text 8"/>
+          <p:cNvSpPr/>
+          <p:nvPr/>
+        </p:nvSpPr>
+        <p:spPr>
+          <a:xfrm>
+            <a:off x="1005840" y="2880360"/>
+            <a:ext cx="2834640" cy="2194560"/>
+          </a:xfrm>
+          <a:prstGeom prst="rect">
+            <a:avLst/>
+          </a:prstGeom>
+          <a:noFill/>
+          <a:ln/>
+        </p:spPr>
+        <p:txBody>
+          <a:bodyPr wrap="square" rtlCol="0" anchor="ctr"/>
+          <a:lstStyle/>
+          <a:p>
+            <a:pPr indent="0" marL="0">
+              <a:buNone/>
+            </a:pPr>
+            <a:r>
+              <a:rPr lang="en-US" sz="950" dirty="0">
                 <a:solidFill>
                   <a:srgbClr val="CBD5E1"/>
                 </a:solidFill>
@@ -5537,22 +5576,22 @@
                 <a:ea typeface="Arial" pitchFamily="34" charset="-122"/>
                 <a:cs typeface="Arial" pitchFamily="34" charset="-120"/>
               </a:rPr>
-              <a:t>• Crumpled &amp; Folded Paper: Carbon copies and folds produce character garbage (e.g. "T4b M3t0l4r" instead of Metolar).</a:t>
-            </a:r>
-            <a:endParaRPr lang="en-US" sz="1050" dirty="0"/>
-          </a:p>
-          <a:p>
-            <a:pPr indent="0" marL="0">
-              <a:buNone/>
-            </a:pPr>
-            <a:endParaRPr lang="en-US" sz="1050" dirty="0"/>
-          </a:p>
-          <a:p>
-            <a:pPr indent="0" marL="0">
-              <a:buNone/>
-            </a:pPr>
-            <a:r>
-              <a:rPr lang="en-US" sz="1050" dirty="0">
+              <a:t>• Trained on biomedical research literature, clinical trials &amp; EHR notes (Med-PaLM 2 evolution)</a:t>
+            </a:r>
+            <a:endParaRPr lang="en-US" sz="950" dirty="0"/>
+          </a:p>
+          <a:p>
+            <a:pPr indent="0" marL="0">
+              <a:buNone/>
+            </a:pPr>
+            <a:endParaRPr lang="en-US" sz="950" dirty="0"/>
+          </a:p>
+          <a:p>
+            <a:pPr indent="0" marL="0">
+              <a:buNone/>
+            </a:pPr>
+            <a:r>
+              <a:rPr lang="en-US" sz="950" dirty="0">
                 <a:solidFill>
                   <a:srgbClr val="CBD5E1"/>
                 </a:solidFill>
@@ -5560,22 +5599,22 @@
                 <a:ea typeface="Arial" pitchFamily="34" charset="-122"/>
                 <a:cs typeface="Arial" pitchFamily="34" charset="-120"/>
               </a:rPr>
-              <a:t>• Fragmented Spatial Tables: OCR loses row/column relationships across multi-page summaries, mixing dosages across drugs.</a:t>
-            </a:r>
-            <a:endParaRPr lang="en-US" sz="1050" dirty="0"/>
-          </a:p>
-          <a:p>
-            <a:pPr indent="0" marL="0">
-              <a:buNone/>
-            </a:pPr>
-            <a:endParaRPr lang="en-US" sz="1050" dirty="0"/>
-          </a:p>
-          <a:p>
-            <a:pPr indent="0" marL="0">
-              <a:buNone/>
-            </a:pPr>
-            <a:r>
-              <a:rPr lang="en-US" sz="1050" dirty="0">
+              <a:t>• Understands surgical post-op courses and procedural care protocols</a:t>
+            </a:r>
+            <a:endParaRPr lang="en-US" sz="950" dirty="0"/>
+          </a:p>
+          <a:p>
+            <a:pPr indent="0" marL="0">
+              <a:buNone/>
+            </a:pPr>
+            <a:endParaRPr lang="en-US" sz="950" dirty="0"/>
+          </a:p>
+          <a:p>
+            <a:pPr indent="0" marL="0">
+              <a:buNone/>
+            </a:pPr>
+            <a:r>
+              <a:rPr lang="en-US" sz="950" dirty="0">
                 <a:solidFill>
                   <a:srgbClr val="CBD5E1"/>
                 </a:solidFill>
@@ -5583,22 +5622,22 @@
                 <a:ea typeface="Arial" pitchFamily="34" charset="-122"/>
                 <a:cs typeface="Arial" pitchFamily="34" charset="-120"/>
               </a:rPr>
-              <a:t>• No Medical Semantic Understanding: Traditional OCR cannot distinguish between a discontinued allergy medication and an active prescription.</a:t>
-            </a:r>
-            <a:endParaRPr lang="en-US" sz="1050" dirty="0"/>
-          </a:p>
-          <a:p>
-            <a:pPr indent="0" marL="0">
-              <a:buNone/>
-            </a:pPr>
-            <a:endParaRPr lang="en-US" sz="1050" dirty="0"/>
-          </a:p>
-          <a:p>
-            <a:pPr indent="0" marL="0">
-              <a:buNone/>
-            </a:pPr>
-            <a:r>
-              <a:rPr lang="en-US" sz="1050" dirty="0">
+              <a:t>• Evaluates clinical contraindications &amp; multi-drug regimens without prompt drift</a:t>
+            </a:r>
+            <a:endParaRPr lang="en-US" sz="950" dirty="0"/>
+          </a:p>
+          <a:p>
+            <a:pPr indent="0" marL="0">
+              <a:buNone/>
+            </a:pPr>
+            <a:endParaRPr lang="en-US" sz="950" dirty="0"/>
+          </a:p>
+          <a:p>
+            <a:pPr indent="0" marL="0">
+              <a:buNone/>
+            </a:pPr>
+            <a:r>
+              <a:rPr lang="en-US" sz="950" dirty="0">
                 <a:solidFill>
                   <a:srgbClr val="CBD5E1"/>
                 </a:solidFill>
@@ -5606,28 +5645,450 @@
                 <a:ea typeface="Arial" pitchFamily="34" charset="-122"/>
                 <a:cs typeface="Arial" pitchFamily="34" charset="-120"/>
               </a:rPr>
-              <a:t>• Slow Multi-Step Lag: Chaining Tesseract OCR + Text Cleaner + LLM Parser takes 18-25 seconds with cascading errors.</a:t>
-            </a:r>
-            <a:endParaRPr lang="en-US" sz="1050" dirty="0"/>
-          </a:p>
-        </p:txBody>
-      </p:sp>
-      <p:sp>
-        <p:nvSpPr>
-          <p:cNvPr id="10" name="Shape 8"/>
-          <p:cNvSpPr/>
-          <p:nvPr/>
-        </p:nvSpPr>
-        <p:spPr>
-          <a:xfrm>
-            <a:off x="6217920" y="1920240"/>
-            <a:ext cx="5212080" cy="3108960"/>
+              <a:t>• Enforces structured JSON clinical schemas for downstream workflows</a:t>
+            </a:r>
+            <a:endParaRPr lang="en-US" sz="950" dirty="0"/>
+          </a:p>
+        </p:txBody>
+      </p:sp>
+      <p:sp>
+        <p:nvSpPr>
+          <p:cNvPr id="11" name="Shape 9"/>
+          <p:cNvSpPr/>
+          <p:nvPr/>
+        </p:nvSpPr>
+        <p:spPr>
+          <a:xfrm>
+            <a:off x="4389120" y="1920240"/>
+            <a:ext cx="3383280" cy="3291840"/>
           </a:xfrm>
           <a:prstGeom prst="roundRect">
             <a:avLst/>
           </a:prstGeom>
           <a:solidFill>
             <a:srgbClr val="0F172A"/>
+          </a:solidFill>
+          <a:ln w="19050">
+            <a:solidFill>
+              <a:srgbClr val="14B8A6"/>
+            </a:solidFill>
+            <a:prstDash val="solid"/>
+          </a:ln>
+        </p:spPr>
+      </p:sp>
+      <p:sp>
+        <p:nvSpPr>
+          <p:cNvPr id="12" name="Text 10"/>
+          <p:cNvSpPr/>
+          <p:nvPr/>
+        </p:nvSpPr>
+        <p:spPr>
+          <a:xfrm>
+            <a:off x="4663440" y="2103120"/>
+            <a:ext cx="2834640" cy="228600"/>
+          </a:xfrm>
+          <a:prstGeom prst="rect">
+            <a:avLst/>
+          </a:prstGeom>
+          <a:noFill/>
+          <a:ln/>
+        </p:spPr>
+        <p:txBody>
+          <a:bodyPr wrap="square" rtlCol="0" anchor="ctr"/>
+          <a:lstStyle/>
+          <a:p>
+            <a:pPr indent="0" marL="0">
+              <a:buNone/>
+            </a:pPr>
+            <a:r>
+              <a:rPr lang="en-US" sz="850" b="1" dirty="0">
+                <a:solidFill>
+                  <a:srgbClr val="14B8A6"/>
+                </a:solidFill>
+                <a:latin typeface="Arial" pitchFamily="34" charset="0"/>
+                <a:ea typeface="Arial" pitchFamily="34" charset="-122"/>
+                <a:cs typeface="Arial" pitchFamily="34" charset="-120"/>
+              </a:rPr>
+              <a:t>MULTIMODAL INGESTION</a:t>
+            </a:r>
+            <a:endParaRPr lang="en-US" sz="850" dirty="0"/>
+          </a:p>
+        </p:txBody>
+      </p:sp>
+      <p:sp>
+        <p:nvSpPr>
+          <p:cNvPr id="13" name="Text 11"/>
+          <p:cNvSpPr/>
+          <p:nvPr/>
+        </p:nvSpPr>
+        <p:spPr>
+          <a:xfrm>
+            <a:off x="4663440" y="2377440"/>
+            <a:ext cx="2834640" cy="411480"/>
+          </a:xfrm>
+          <a:prstGeom prst="rect">
+            <a:avLst/>
+          </a:prstGeom>
+          <a:noFill/>
+          <a:ln/>
+        </p:spPr>
+        <p:txBody>
+          <a:bodyPr wrap="square" rtlCol="0" anchor="ctr"/>
+          <a:lstStyle/>
+          <a:p>
+            <a:pPr indent="0" marL="0">
+              <a:buNone/>
+            </a:pPr>
+            <a:r>
+              <a:rPr lang="en-US" sz="1300" b="1" dirty="0">
+                <a:solidFill>
+                  <a:srgbClr val="FFFFFF"/>
+                </a:solidFill>
+                <a:latin typeface="Arial" pitchFamily="34" charset="0"/>
+                <a:ea typeface="Arial" pitchFamily="34" charset="-122"/>
+                <a:cs typeface="Arial" pitchFamily="34" charset="-120"/>
+              </a:rPr>
+              <a:t>Gemini 2.5 Flash Vision</a:t>
+            </a:r>
+            <a:endParaRPr lang="en-US" sz="1300" dirty="0"/>
+          </a:p>
+        </p:txBody>
+      </p:sp>
+      <p:sp>
+        <p:nvSpPr>
+          <p:cNvPr id="14" name="Text 12"/>
+          <p:cNvSpPr/>
+          <p:nvPr/>
+        </p:nvSpPr>
+        <p:spPr>
+          <a:xfrm>
+            <a:off x="4663440" y="2880360"/>
+            <a:ext cx="2834640" cy="2194560"/>
+          </a:xfrm>
+          <a:prstGeom prst="rect">
+            <a:avLst/>
+          </a:prstGeom>
+          <a:noFill/>
+          <a:ln/>
+        </p:spPr>
+        <p:txBody>
+          <a:bodyPr wrap="square" rtlCol="0" anchor="ctr"/>
+          <a:lstStyle/>
+          <a:p>
+            <a:pPr indent="0" marL="0">
+              <a:buNone/>
+            </a:pPr>
+            <a:r>
+              <a:rPr lang="en-US" sz="950" dirty="0">
+                <a:solidFill>
+                  <a:srgbClr val="CBD5E1"/>
+                </a:solidFill>
+                <a:latin typeface="Arial" pitchFamily="34" charset="0"/>
+                <a:ea typeface="Arial" pitchFamily="34" charset="-122"/>
+                <a:cs typeface="Arial" pitchFamily="34" charset="-120"/>
+              </a:rPr>
+              <a:t>• Direct native pixel-to-fact parser cracking folded, crumpled &amp; carbon-copy hospital papers in 1.2s</a:t>
+            </a:r>
+            <a:endParaRPr lang="en-US" sz="950" dirty="0"/>
+          </a:p>
+          <a:p>
+            <a:pPr indent="0" marL="0">
+              <a:buNone/>
+            </a:pPr>
+            <a:endParaRPr lang="en-US" sz="950" dirty="0"/>
+          </a:p>
+          <a:p>
+            <a:pPr indent="0" marL="0">
+              <a:buNone/>
+            </a:pPr>
+            <a:r>
+              <a:rPr lang="en-US" sz="950" dirty="0">
+                <a:solidFill>
+                  <a:srgbClr val="CBD5E1"/>
+                </a:solidFill>
+                <a:latin typeface="Arial" pitchFamily="34" charset="0"/>
+                <a:ea typeface="Arial" pitchFamily="34" charset="-122"/>
+                <a:cs typeface="Arial" pitchFamily="34" charset="-120"/>
+              </a:rPr>
+              <a:t>• Pre-flight document classifier validates clinical authenticity &amp; computes confidence score</a:t>
+            </a:r>
+            <a:endParaRPr lang="en-US" sz="950" dirty="0"/>
+          </a:p>
+          <a:p>
+            <a:pPr indent="0" marL="0">
+              <a:buNone/>
+            </a:pPr>
+            <a:endParaRPr lang="en-US" sz="950" dirty="0"/>
+          </a:p>
+          <a:p>
+            <a:pPr indent="0" marL="0">
+              <a:buNone/>
+            </a:pPr>
+            <a:r>
+              <a:rPr lang="en-US" sz="950" dirty="0">
+                <a:solidFill>
+                  <a:srgbClr val="CBD5E1"/>
+                </a:solidFill>
+                <a:latin typeface="Arial" pitchFamily="34" charset="0"/>
+                <a:ea typeface="Arial" pitchFamily="34" charset="-122"/>
+                <a:cs typeface="Arial" pitchFamily="34" charset="-120"/>
+              </a:rPr>
+              <a:t>• Extracts spatial multi-column prescription tables and handwritten addendums</a:t>
+            </a:r>
+            <a:endParaRPr lang="en-US" sz="950" dirty="0"/>
+          </a:p>
+          <a:p>
+            <a:pPr indent="0" marL="0">
+              <a:buNone/>
+            </a:pPr>
+            <a:endParaRPr lang="en-US" sz="950" dirty="0"/>
+          </a:p>
+          <a:p>
+            <a:pPr indent="0" marL="0">
+              <a:buNone/>
+            </a:pPr>
+            <a:r>
+              <a:rPr lang="en-US" sz="950" dirty="0">
+                <a:solidFill>
+                  <a:srgbClr val="CBD5E1"/>
+                </a:solidFill>
+                <a:latin typeface="Arial" pitchFamily="34" charset="0"/>
+                <a:ea typeface="Arial" pitchFamily="34" charset="-122"/>
+                <a:cs typeface="Arial" pitchFamily="34" charset="-120"/>
+              </a:rPr>
+              <a:t>• 94.6% entity extraction accuracy on authentic Indian hospital summaries</a:t>
+            </a:r>
+            <a:endParaRPr lang="en-US" sz="950" dirty="0"/>
+          </a:p>
+        </p:txBody>
+      </p:sp>
+      <p:sp>
+        <p:nvSpPr>
+          <p:cNvPr id="15" name="Shape 13"/>
+          <p:cNvSpPr/>
+          <p:nvPr/>
+        </p:nvSpPr>
+        <p:spPr>
+          <a:xfrm>
+            <a:off x="8046720" y="1920240"/>
+            <a:ext cx="3383280" cy="3291840"/>
+          </a:xfrm>
+          <a:prstGeom prst="roundRect">
+            <a:avLst/>
+          </a:prstGeom>
+          <a:solidFill>
+            <a:srgbClr val="0F172A"/>
+          </a:solidFill>
+          <a:ln w="19050">
+            <a:solidFill>
+              <a:srgbClr val="F59E0B"/>
+            </a:solidFill>
+            <a:prstDash val="solid"/>
+          </a:ln>
+        </p:spPr>
+      </p:sp>
+      <p:sp>
+        <p:nvSpPr>
+          <p:cNvPr id="16" name="Text 14"/>
+          <p:cNvSpPr/>
+          <p:nvPr/>
+        </p:nvSpPr>
+        <p:spPr>
+          <a:xfrm>
+            <a:off x="8321040" y="2103120"/>
+            <a:ext cx="2834640" cy="228600"/>
+          </a:xfrm>
+          <a:prstGeom prst="rect">
+            <a:avLst/>
+          </a:prstGeom>
+          <a:noFill/>
+          <a:ln/>
+        </p:spPr>
+        <p:txBody>
+          <a:bodyPr wrap="square" rtlCol="0" anchor="ctr"/>
+          <a:lstStyle/>
+          <a:p>
+            <a:pPr indent="0" marL="0">
+              <a:buNone/>
+            </a:pPr>
+            <a:r>
+              <a:rPr lang="en-US" sz="850" b="1" dirty="0">
+                <a:solidFill>
+                  <a:srgbClr val="F59E0B"/>
+                </a:solidFill>
+                <a:latin typeface="Arial" pitchFamily="34" charset="0"/>
+                <a:ea typeface="Arial" pitchFamily="34" charset="-122"/>
+                <a:cs typeface="Arial" pitchFamily="34" charset="-120"/>
+              </a:rPr>
+              <a:t>INDIAN MEDICAL FORMULARY</a:t>
+            </a:r>
+            <a:endParaRPr lang="en-US" sz="850" dirty="0"/>
+          </a:p>
+        </p:txBody>
+      </p:sp>
+      <p:sp>
+        <p:nvSpPr>
+          <p:cNvPr id="17" name="Text 15"/>
+          <p:cNvSpPr/>
+          <p:nvPr/>
+        </p:nvSpPr>
+        <p:spPr>
+          <a:xfrm>
+            <a:off x="8321040" y="2377440"/>
+            <a:ext cx="2834640" cy="411480"/>
+          </a:xfrm>
+          <a:prstGeom prst="rect">
+            <a:avLst/>
+          </a:prstGeom>
+          <a:noFill/>
+          <a:ln/>
+        </p:spPr>
+        <p:txBody>
+          <a:bodyPr wrap="square" rtlCol="0" anchor="ctr"/>
+          <a:lstStyle/>
+          <a:p>
+            <a:pPr indent="0" marL="0">
+              <a:buNone/>
+            </a:pPr>
+            <a:r>
+              <a:rPr lang="en-US" sz="1300" b="1" dirty="0">
+                <a:solidFill>
+                  <a:srgbClr val="FFFFFF"/>
+                </a:solidFill>
+                <a:latin typeface="Arial" pitchFamily="34" charset="0"/>
+                <a:ea typeface="Arial" pitchFamily="34" charset="-122"/>
+                <a:cs typeface="Arial" pitchFamily="34" charset="-120"/>
+              </a:rPr>
+              <a:t>CDSCO &amp; PMBJP Registry</a:t>
+            </a:r>
+            <a:endParaRPr lang="en-US" sz="1300" dirty="0"/>
+          </a:p>
+        </p:txBody>
+      </p:sp>
+      <p:sp>
+        <p:nvSpPr>
+          <p:cNvPr id="18" name="Text 16"/>
+          <p:cNvSpPr/>
+          <p:nvPr/>
+        </p:nvSpPr>
+        <p:spPr>
+          <a:xfrm>
+            <a:off x="8321040" y="2880360"/>
+            <a:ext cx="2834640" cy="2194560"/>
+          </a:xfrm>
+          <a:prstGeom prst="rect">
+            <a:avLst/>
+          </a:prstGeom>
+          <a:noFill/>
+          <a:ln/>
+        </p:spPr>
+        <p:txBody>
+          <a:bodyPr wrap="square" rtlCol="0" anchor="ctr"/>
+          <a:lstStyle/>
+          <a:p>
+            <a:pPr indent="0" marL="0">
+              <a:buNone/>
+            </a:pPr>
+            <a:r>
+              <a:rPr lang="en-US" sz="950" dirty="0">
+                <a:solidFill>
+                  <a:srgbClr val="CBD5E1"/>
+                </a:solidFill>
+                <a:latin typeface="Arial" pitchFamily="34" charset="0"/>
+                <a:ea typeface="Arial" pitchFamily="34" charset="-122"/>
+                <a:cs typeface="Arial" pitchFamily="34" charset="-120"/>
+              </a:rPr>
+              <a:t>• Resolves proprietary Indian brands (Metolar, Pan-D, Augmentin, Zerodol) to active chemical salts</a:t>
+            </a:r>
+            <a:endParaRPr lang="en-US" sz="950" dirty="0"/>
+          </a:p>
+          <a:p>
+            <a:pPr indent="0" marL="0">
+              <a:buNone/>
+            </a:pPr>
+            <a:endParaRPr lang="en-US" sz="950" dirty="0"/>
+          </a:p>
+          <a:p>
+            <a:pPr indent="0" marL="0">
+              <a:buNone/>
+            </a:pPr>
+            <a:r>
+              <a:rPr lang="en-US" sz="950" dirty="0">
+                <a:solidFill>
+                  <a:srgbClr val="CBD5E1"/>
+                </a:solidFill>
+                <a:latin typeface="Arial" pitchFamily="34" charset="0"/>
+                <a:ea typeface="Arial" pitchFamily="34" charset="-122"/>
+                <a:cs typeface="Arial" pitchFamily="34" charset="-120"/>
+              </a:rPr>
+              <a:t>• Validates approved Fixed-Dose Combinations (FDCs) &amp; Schedule H1 antibiotic surveillance</a:t>
+            </a:r>
+            <a:endParaRPr lang="en-US" sz="950" dirty="0"/>
+          </a:p>
+          <a:p>
+            <a:pPr indent="0" marL="0">
+              <a:buNone/>
+            </a:pPr>
+            <a:endParaRPr lang="en-US" sz="950" dirty="0"/>
+          </a:p>
+          <a:p>
+            <a:pPr indent="0" marL="0">
+              <a:buNone/>
+            </a:pPr>
+            <a:r>
+              <a:rPr lang="en-US" sz="950" dirty="0">
+                <a:solidFill>
+                  <a:srgbClr val="CBD5E1"/>
+                </a:solidFill>
+                <a:latin typeface="Arial" pitchFamily="34" charset="0"/>
+                <a:ea typeface="Arial" pitchFamily="34" charset="-122"/>
+                <a:cs typeface="Arial" pitchFamily="34" charset="-120"/>
+              </a:rPr>
+              <a:t>• PMBJP Jan Aushadhi generic pairing computes up to 85% family savings (₹28 vs ₹168/mo)</a:t>
+            </a:r>
+            <a:endParaRPr lang="en-US" sz="950" dirty="0"/>
+          </a:p>
+          <a:p>
+            <a:pPr indent="0" marL="0">
+              <a:buNone/>
+            </a:pPr>
+            <a:endParaRPr lang="en-US" sz="950" dirty="0"/>
+          </a:p>
+          <a:p>
+            <a:pPr indent="0" marL="0">
+              <a:buNone/>
+            </a:pPr>
+            <a:r>
+              <a:rPr lang="en-US" sz="950" dirty="0">
+                <a:solidFill>
+                  <a:srgbClr val="CBD5E1"/>
+                </a:solidFill>
+                <a:latin typeface="Arial" pitchFamily="34" charset="0"/>
+                <a:ea typeface="Arial" pitchFamily="34" charset="-122"/>
+                <a:cs typeface="Arial" pitchFamily="34" charset="-120"/>
+              </a:rPr>
+              <a:t>• Standardized NRCeS SNOMED-CT India Extension codes for ABDM interoperability</a:t>
+            </a:r>
+            <a:endParaRPr lang="en-US" sz="950" dirty="0"/>
+          </a:p>
+        </p:txBody>
+      </p:sp>
+      <p:sp>
+        <p:nvSpPr>
+          <p:cNvPr id="19" name="Shape 17"/>
+          <p:cNvSpPr/>
+          <p:nvPr/>
+        </p:nvSpPr>
+        <p:spPr>
+          <a:xfrm>
+            <a:off x="731520" y="5394960"/>
+            <a:ext cx="10698480" cy="731520"/>
+          </a:xfrm>
+          <a:prstGeom prst="roundRect">
+            <a:avLst/>
+          </a:prstGeom>
+          <a:solidFill>
+            <a:srgbClr val="020617"/>
           </a:solidFill>
           <a:ln w="12700">
             <a:solidFill>
@@ -5639,30 +6100,30 @@
       </p:sp>
       <p:sp>
         <p:nvSpPr>
-          <p:cNvPr id="11" name="Text 9"/>
-          <p:cNvSpPr/>
-          <p:nvPr/>
-        </p:nvSpPr>
-        <p:spPr>
-          <a:xfrm>
-            <a:off x="6492240" y="2103120"/>
-            <a:ext cx="4663440" cy="365760"/>
-          </a:xfrm>
-          <a:prstGeom prst="rect">
-            <a:avLst/>
-          </a:prstGeom>
-          <a:noFill/>
-          <a:ln/>
-        </p:spPr>
-        <p:txBody>
-          <a:bodyPr wrap="square" rtlCol="0" anchor="ctr"/>
-          <a:lstStyle/>
-          <a:p>
-            <a:pPr indent="0" marL="0">
-              <a:buNone/>
-            </a:pPr>
-            <a:r>
-              <a:rPr lang="en-US" sz="1200" b="1" dirty="0">
+          <p:cNvPr id="20" name="Text 18"/>
+          <p:cNvSpPr/>
+          <p:nvPr/>
+        </p:nvSpPr>
+        <p:spPr>
+          <a:xfrm>
+            <a:off x="914400" y="5623560"/>
+            <a:ext cx="10332720" cy="320040"/>
+          </a:xfrm>
+          <a:prstGeom prst="rect">
+            <a:avLst/>
+          </a:prstGeom>
+          <a:noFill/>
+          <a:ln/>
+        </p:spPr>
+        <p:txBody>
+          <a:bodyPr wrap="square" rtlCol="0" anchor="ctr"/>
+          <a:lstStyle/>
+          <a:p>
+            <a:pPr algn="ctr" indent="0" marL="0">
+              <a:buNone/>
+            </a:pPr>
+            <a:r>
+              <a:rPr lang="en-US" sz="1050" b="1" dirty="0">
                 <a:solidFill>
                   <a:srgbClr val="14B8A6"/>
                 </a:solidFill>
@@ -5670,181 +6131,9 @@
                 <a:ea typeface="Arial" pitchFamily="34" charset="-122"/>
                 <a:cs typeface="Arial" pitchFamily="34" charset="-120"/>
               </a:rPr>
-              <a:t>✨ GEMINI 2.5 FLASH MULTIMODAL EXTRACTION</a:t>
-            </a:r>
-            <a:endParaRPr lang="en-US" sz="1200" dirty="0"/>
-          </a:p>
-        </p:txBody>
-      </p:sp>
-      <p:sp>
-        <p:nvSpPr>
-          <p:cNvPr id="12" name="Text 10"/>
-          <p:cNvSpPr/>
-          <p:nvPr/>
-        </p:nvSpPr>
-        <p:spPr>
-          <a:xfrm>
-            <a:off x="6492240" y="2560320"/>
-            <a:ext cx="4663440" cy="2286000"/>
-          </a:xfrm>
-          <a:prstGeom prst="rect">
-            <a:avLst/>
-          </a:prstGeom>
-          <a:noFill/>
-          <a:ln/>
-        </p:spPr>
-        <p:txBody>
-          <a:bodyPr wrap="square" rtlCol="0" anchor="ctr"/>
-          <a:lstStyle/>
-          <a:p>
-            <a:pPr indent="0" marL="0">
-              <a:buNone/>
-            </a:pPr>
-            <a:r>
-              <a:rPr lang="en-US" sz="1050" dirty="0">
-                <a:solidFill>
-                  <a:srgbClr val="CBD5E1"/>
-                </a:solidFill>
-                <a:latin typeface="Arial" pitchFamily="34" charset="0"/>
-                <a:ea typeface="Arial" pitchFamily="34" charset="-122"/>
-                <a:cs typeface="Arial" pitchFamily="34" charset="-120"/>
-              </a:rPr>
-              <a:t>• Direct Native Pixel-to-Fact Ingestion: Vision encoder reads layout, bold headers, handwritten doctor addendums &amp; signatures in one pass.</a:t>
+              <a:t>ABDM COMPLIANT: NRCeS SNOMED-CT India Extension • CDSCO Formulary • 14-Digit ABHA ID Health Locker Ready</a:t>
             </a:r>
             <a:endParaRPr lang="en-US" sz="1050" dirty="0"/>
-          </a:p>
-          <a:p>
-            <a:pPr indent="0" marL="0">
-              <a:buNone/>
-            </a:pPr>
-            <a:endParaRPr lang="en-US" sz="1050" dirty="0"/>
-          </a:p>
-          <a:p>
-            <a:pPr indent="0" marL="0">
-              <a:buNone/>
-            </a:pPr>
-            <a:r>
-              <a:rPr lang="en-US" sz="1050" dirty="0">
-                <a:solidFill>
-                  <a:srgbClr val="CBD5E1"/>
-                </a:solidFill>
-                <a:latin typeface="Arial" pitchFamily="34" charset="0"/>
-                <a:ea typeface="Arial" pitchFamily="34" charset="-122"/>
-                <a:cs typeface="Arial" pitchFamily="34" charset="-120"/>
-              </a:rPr>
-              <a:t>• Pre-Flight Document Classifier: Automatically validates clinical document type, rejecting electric bills or selfies before processing.</a:t>
-            </a:r>
-            <a:endParaRPr lang="en-US" sz="1050" dirty="0"/>
-          </a:p>
-          <a:p>
-            <a:pPr indent="0" marL="0">
-              <a:buNone/>
-            </a:pPr>
-            <a:endParaRPr lang="en-US" sz="1050" dirty="0"/>
-          </a:p>
-          <a:p>
-            <a:pPr indent="0" marL="0">
-              <a:buNone/>
-            </a:pPr>
-            <a:r>
-              <a:rPr lang="en-US" sz="1050" dirty="0">
-                <a:solidFill>
-                  <a:srgbClr val="CBD5E1"/>
-                </a:solidFill>
-                <a:latin typeface="Arial" pitchFamily="34" charset="0"/>
-                <a:ea typeface="Arial" pitchFamily="34" charset="-122"/>
-                <a:cs typeface="Arial" pitchFamily="34" charset="-120"/>
-              </a:rPr>
-              <a:t>• Strict JSON Clinical Schema Enforcement: Extracted diagnoses, procedures, medicines, and red flags conform to typed clinical structure.</a:t>
-            </a:r>
-            <a:endParaRPr lang="en-US" sz="1050" dirty="0"/>
-          </a:p>
-          <a:p>
-            <a:pPr indent="0" marL="0">
-              <a:buNone/>
-            </a:pPr>
-            <a:endParaRPr lang="en-US" sz="1050" dirty="0"/>
-          </a:p>
-          <a:p>
-            <a:pPr indent="0" marL="0">
-              <a:buNone/>
-            </a:pPr>
-            <a:r>
-              <a:rPr lang="en-US" sz="1050" dirty="0">
-                <a:solidFill>
-                  <a:srgbClr val="CBD5E1"/>
-                </a:solidFill>
-                <a:latin typeface="Arial" pitchFamily="34" charset="0"/>
-                <a:ea typeface="Arial" pitchFamily="34" charset="-122"/>
-                <a:cs typeface="Arial" pitchFamily="34" charset="-120"/>
-              </a:rPr>
-              <a:t>• 1.2s Real-Time Latency: Rapid response enables immediate nurse review without blocking patient ward handover.</a:t>
-            </a:r>
-            <a:endParaRPr lang="en-US" sz="1050" dirty="0"/>
-          </a:p>
-        </p:txBody>
-      </p:sp>
-      <p:sp>
-        <p:nvSpPr>
-          <p:cNvPr id="13" name="Shape 11"/>
-          <p:cNvSpPr/>
-          <p:nvPr/>
-        </p:nvSpPr>
-        <p:spPr>
-          <a:xfrm>
-            <a:off x="731520" y="5212080"/>
-            <a:ext cx="10698480" cy="822960"/>
-          </a:xfrm>
-          <a:prstGeom prst="roundRect">
-            <a:avLst/>
-          </a:prstGeom>
-          <a:solidFill>
-            <a:srgbClr val="042F2E"/>
-          </a:solidFill>
-          <a:ln w="12700">
-            <a:solidFill>
-              <a:srgbClr val="14B8A6"/>
-            </a:solidFill>
-            <a:prstDash val="solid"/>
-          </a:ln>
-        </p:spPr>
-      </p:sp>
-      <p:sp>
-        <p:nvSpPr>
-          <p:cNvPr id="14" name="Text 12"/>
-          <p:cNvSpPr/>
-          <p:nvPr/>
-        </p:nvSpPr>
-        <p:spPr>
-          <a:xfrm>
-            <a:off x="914400" y="5440680"/>
-            <a:ext cx="10332720" cy="365760"/>
-          </a:xfrm>
-          <a:prstGeom prst="rect">
-            <a:avLst/>
-          </a:prstGeom>
-          <a:noFill/>
-          <a:ln/>
-        </p:spPr>
-        <p:txBody>
-          <a:bodyPr wrap="square" rtlCol="0" anchor="ctr"/>
-          <a:lstStyle/>
-          <a:p>
-            <a:pPr algn="ctr" indent="0" marL="0">
-              <a:buNone/>
-            </a:pPr>
-            <a:r>
-              <a:rPr lang="en-US" sz="1100" b="1" dirty="0">
-                <a:solidFill>
-                  <a:srgbClr val="14B8A6"/>
-                </a:solidFill>
-                <a:latin typeface="Arial" pitchFamily="34" charset="0"/>
-                <a:ea typeface="Arial" pitchFamily="34" charset="-122"/>
-                <a:cs typeface="Arial" pitchFamily="34" charset="-120"/>
-              </a:rPr>
-              <a:t>BENCHMARK: 94.6% Entity Extraction Accuracy on Real Indian Tertiary Hospital Discharge Papers | Median Latency: 1.2 seconds</a:t>
-            </a:r>
-            <a:endParaRPr lang="en-US" sz="1100" dirty="0"/>
           </a:p>
         </p:txBody>
       </p:sp>
@@ -7600,7 +7889,7 @@
                 <a:ea typeface="Arial" pitchFamily="34" charset="-122"/>
                 <a:cs typeface="Arial" pitchFamily="34" charset="-120"/>
               </a:rPr>
-              <a:t>Google Cloud &amp; National ABDM Ecosystem</a:t>
+              <a:t>Google Healthcare AI &amp; National ABDM Rails</a:t>
             </a:r>
             <a:endParaRPr lang="en-US" sz="2200" dirty="0"/>
           </a:p>
@@ -7639,7 +7928,7 @@
                 <a:ea typeface="Arial" pitchFamily="34" charset="-122"/>
                 <a:cs typeface="Arial" pitchFamily="34" charset="-120"/>
               </a:rPr>
-              <a:t>End-to-End Orchestration of Gemini, Cloud TTS, Google Calendar &amp; Maps Platforms</a:t>
+              <a:t>End-to-End Orchestration of MedLM, Gemini 2.5 Flash, Cloud TTS Neural2 &amp; Google Maps</a:t>
             </a:r>
             <a:endParaRPr lang="en-US" sz="1200" dirty="0"/>
           </a:p>
@@ -7679,7 +7968,7 @@
         <p:spPr>
           <a:xfrm>
             <a:off x="731520" y="1920240"/>
-            <a:ext cx="5212080" cy="1737360"/>
+            <a:ext cx="2011680" cy="3474720"/>
           </a:xfrm>
           <a:prstGeom prst="roundRect">
             <a:avLst/>
@@ -7687,7 +7976,149 @@
           <a:solidFill>
             <a:srgbClr val="0F172A"/>
           </a:solidFill>
-          <a:ln w="12700">
+          <a:ln w="19050">
+            <a:solidFill>
+              <a:srgbClr val="C084FC"/>
+            </a:solidFill>
+            <a:prstDash val="solid"/>
+          </a:ln>
+        </p:spPr>
+      </p:sp>
+      <p:sp>
+        <p:nvSpPr>
+          <p:cNvPr id="8" name="Text 6"/>
+          <p:cNvSpPr/>
+          <p:nvPr/>
+        </p:nvSpPr>
+        <p:spPr>
+          <a:xfrm>
+            <a:off x="868680" y="2103120"/>
+            <a:ext cx="1737360" cy="411480"/>
+          </a:xfrm>
+          <a:prstGeom prst="rect">
+            <a:avLst/>
+          </a:prstGeom>
+          <a:noFill/>
+          <a:ln/>
+        </p:spPr>
+        <p:txBody>
+          <a:bodyPr wrap="square" rtlCol="0" anchor="ctr"/>
+          <a:lstStyle/>
+          <a:p>
+            <a:pPr indent="0" marL="0">
+              <a:buNone/>
+            </a:pPr>
+            <a:r>
+              <a:rPr lang="en-US" sz="1200" b="1" dirty="0">
+                <a:solidFill>
+                  <a:srgbClr val="C084FC"/>
+                </a:solidFill>
+                <a:latin typeface="Arial" pitchFamily="34" charset="0"/>
+                <a:ea typeface="Arial" pitchFamily="34" charset="-122"/>
+                <a:cs typeface="Arial" pitchFamily="34" charset="-120"/>
+              </a:rPr>
+              <a:t>Google MedLM</a:t>
+            </a:r>
+            <a:endParaRPr lang="en-US" sz="1200" dirty="0"/>
+          </a:p>
+        </p:txBody>
+      </p:sp>
+      <p:sp>
+        <p:nvSpPr>
+          <p:cNvPr id="9" name="Text 7"/>
+          <p:cNvSpPr/>
+          <p:nvPr/>
+        </p:nvSpPr>
+        <p:spPr>
+          <a:xfrm>
+            <a:off x="868680" y="2560320"/>
+            <a:ext cx="1737360" cy="320040"/>
+          </a:xfrm>
+          <a:prstGeom prst="rect">
+            <a:avLst/>
+          </a:prstGeom>
+          <a:noFill/>
+          <a:ln/>
+        </p:spPr>
+        <p:txBody>
+          <a:bodyPr wrap="square" rtlCol="0" anchor="ctr"/>
+          <a:lstStyle/>
+          <a:p>
+            <a:pPr indent="0" marL="0">
+              <a:buNone/>
+            </a:pPr>
+            <a:r>
+              <a:rPr lang="en-US" sz="800" b="1" dirty="0">
+                <a:solidFill>
+                  <a:srgbClr val="94A3B8"/>
+                </a:solidFill>
+                <a:latin typeface="Arial" pitchFamily="34" charset="0"/>
+                <a:ea typeface="Arial" pitchFamily="34" charset="-122"/>
+                <a:cs typeface="Arial" pitchFamily="34" charset="-120"/>
+              </a:rPr>
+              <a:t>BIOMEDICAL FOUNDATION LLM</a:t>
+            </a:r>
+            <a:endParaRPr lang="en-US" sz="800" dirty="0"/>
+          </a:p>
+        </p:txBody>
+      </p:sp>
+      <p:sp>
+        <p:nvSpPr>
+          <p:cNvPr id="10" name="Text 8"/>
+          <p:cNvSpPr/>
+          <p:nvPr/>
+        </p:nvSpPr>
+        <p:spPr>
+          <a:xfrm>
+            <a:off x="868680" y="2971800"/>
+            <a:ext cx="1737360" cy="2103120"/>
+          </a:xfrm>
+          <a:prstGeom prst="rect">
+            <a:avLst/>
+          </a:prstGeom>
+          <a:noFill/>
+          <a:ln/>
+        </p:spPr>
+        <p:txBody>
+          <a:bodyPr wrap="square" rtlCol="0" anchor="ctr"/>
+          <a:lstStyle/>
+          <a:p>
+            <a:pPr indent="0" marL="0">
+              <a:buNone/>
+            </a:pPr>
+            <a:r>
+              <a:rPr lang="en-US" sz="950" dirty="0">
+                <a:solidFill>
+                  <a:srgbClr val="CBD5E1"/>
+                </a:solidFill>
+                <a:latin typeface="Arial" pitchFamily="34" charset="0"/>
+                <a:ea typeface="Arial" pitchFamily="34" charset="-122"/>
+                <a:cs typeface="Arial" pitchFamily="34" charset="-120"/>
+              </a:rPr>
+              <a:t>Vertex AI healthcare model trained on medical clinical literature for deep discharge reasoning.</a:t>
+            </a:r>
+            <a:endParaRPr lang="en-US" sz="950" dirty="0"/>
+          </a:p>
+        </p:txBody>
+      </p:sp>
+      <p:sp>
+        <p:nvSpPr>
+          <p:cNvPr id="11" name="Shape 9"/>
+          <p:cNvSpPr/>
+          <p:nvPr/>
+        </p:nvSpPr>
+        <p:spPr>
+          <a:xfrm>
+            <a:off x="2926080" y="1920240"/>
+            <a:ext cx="2011680" cy="3474720"/>
+          </a:xfrm>
+          <a:prstGeom prst="roundRect">
+            <a:avLst/>
+          </a:prstGeom>
+          <a:solidFill>
+            <a:srgbClr val="0F172A"/>
+          </a:solidFill>
+          <a:ln w="19050">
             <a:solidFill>
               <a:srgbClr val="14B8A6"/>
             </a:solidFill>
@@ -7697,30 +8128,30 @@
       </p:sp>
       <p:sp>
         <p:nvSpPr>
-          <p:cNvPr id="8" name="Text 6"/>
-          <p:cNvSpPr/>
-          <p:nvPr/>
-        </p:nvSpPr>
-        <p:spPr>
-          <a:xfrm>
-            <a:off x="1005840" y="2103120"/>
-            <a:ext cx="4663440" cy="320040"/>
-          </a:xfrm>
-          <a:prstGeom prst="rect">
-            <a:avLst/>
-          </a:prstGeom>
-          <a:noFill/>
-          <a:ln/>
-        </p:spPr>
-        <p:txBody>
-          <a:bodyPr wrap="square" rtlCol="0" anchor="ctr"/>
-          <a:lstStyle/>
-          <a:p>
-            <a:pPr indent="0" marL="0">
-              <a:buNone/>
-            </a:pPr>
-            <a:r>
-              <a:rPr lang="en-US" sz="1400" b="1" dirty="0">
+          <p:cNvPr id="12" name="Text 10"/>
+          <p:cNvSpPr/>
+          <p:nvPr/>
+        </p:nvSpPr>
+        <p:spPr>
+          <a:xfrm>
+            <a:off x="3063240" y="2103120"/>
+            <a:ext cx="1737360" cy="411480"/>
+          </a:xfrm>
+          <a:prstGeom prst="rect">
+            <a:avLst/>
+          </a:prstGeom>
+          <a:noFill/>
+          <a:ln/>
+        </p:spPr>
+        <p:txBody>
+          <a:bodyPr wrap="square" rtlCol="0" anchor="ctr"/>
+          <a:lstStyle/>
+          <a:p>
+            <a:pPr indent="0" marL="0">
+              <a:buNone/>
+            </a:pPr>
+            <a:r>
+              <a:rPr lang="en-US" sz="1200" b="1" dirty="0">
                 <a:solidFill>
                   <a:srgbClr val="14B8A6"/>
                 </a:solidFill>
@@ -7728,38 +8159,38 @@
                 <a:ea typeface="Arial" pitchFamily="34" charset="-122"/>
                 <a:cs typeface="Arial" pitchFamily="34" charset="-120"/>
               </a:rPr>
-              <a:t>Google Gemini 2.5 Flash</a:t>
-            </a:r>
-            <a:endParaRPr lang="en-US" sz="1400" dirty="0"/>
-          </a:p>
-        </p:txBody>
-      </p:sp>
-      <p:sp>
-        <p:nvSpPr>
-          <p:cNvPr id="9" name="Text 7"/>
-          <p:cNvSpPr/>
-          <p:nvPr/>
-        </p:nvSpPr>
-        <p:spPr>
-          <a:xfrm>
-            <a:off x="1005840" y="2423160"/>
-            <a:ext cx="4663440" cy="274320"/>
-          </a:xfrm>
-          <a:prstGeom prst="rect">
-            <a:avLst/>
-          </a:prstGeom>
-          <a:noFill/>
-          <a:ln/>
-        </p:spPr>
-        <p:txBody>
-          <a:bodyPr wrap="square" rtlCol="0" anchor="ctr"/>
-          <a:lstStyle/>
-          <a:p>
-            <a:pPr indent="0" marL="0">
-              <a:buNone/>
-            </a:pPr>
-            <a:r>
-              <a:rPr lang="en-US" sz="900" b="1" dirty="0">
+              <a:t>Gemini 2.5 Flash</a:t>
+            </a:r>
+            <a:endParaRPr lang="en-US" sz="1200" dirty="0"/>
+          </a:p>
+        </p:txBody>
+      </p:sp>
+      <p:sp>
+        <p:nvSpPr>
+          <p:cNvPr id="13" name="Text 11"/>
+          <p:cNvSpPr/>
+          <p:nvPr/>
+        </p:nvSpPr>
+        <p:spPr>
+          <a:xfrm>
+            <a:off x="3063240" y="2560320"/>
+            <a:ext cx="1737360" cy="320040"/>
+          </a:xfrm>
+          <a:prstGeom prst="rect">
+            <a:avLst/>
+          </a:prstGeom>
+          <a:noFill/>
+          <a:ln/>
+        </p:spPr>
+        <p:txBody>
+          <a:bodyPr wrap="square" rtlCol="0" anchor="ctr"/>
+          <a:lstStyle/>
+          <a:p>
+            <a:pPr indent="0" marL="0">
+              <a:buNone/>
+            </a:pPr>
+            <a:r>
+              <a:rPr lang="en-US" sz="800" b="1" dirty="0">
                 <a:solidFill>
                   <a:srgbClr val="94A3B8"/>
                 </a:solidFill>
@@ -7767,38 +8198,38 @@
                 <a:ea typeface="Arial" pitchFamily="34" charset="-122"/>
                 <a:cs typeface="Arial" pitchFamily="34" charset="-120"/>
               </a:rPr>
-              <a:t>MULTIMODAL CLINICAL INGESTION</a:t>
-            </a:r>
-            <a:endParaRPr lang="en-US" sz="900" dirty="0"/>
-          </a:p>
-        </p:txBody>
-      </p:sp>
-      <p:sp>
-        <p:nvSpPr>
-          <p:cNvPr id="10" name="Text 8"/>
-          <p:cNvSpPr/>
-          <p:nvPr/>
-        </p:nvSpPr>
-        <p:spPr>
-          <a:xfrm>
-            <a:off x="1005840" y="2743200"/>
-            <a:ext cx="4663440" cy="777240"/>
-          </a:xfrm>
-          <a:prstGeom prst="rect">
-            <a:avLst/>
-          </a:prstGeom>
-          <a:noFill/>
-          <a:ln/>
-        </p:spPr>
-        <p:txBody>
-          <a:bodyPr wrap="square" rtlCol="0" anchor="ctr"/>
-          <a:lstStyle/>
-          <a:p>
-            <a:pPr indent="0" marL="0">
-              <a:buNone/>
-            </a:pPr>
-            <a:r>
-              <a:rPr lang="en-US" sz="1000" dirty="0">
+              <a:t>MULTIMODAL VISION INGESTION</a:t>
+            </a:r>
+            <a:endParaRPr lang="en-US" sz="800" dirty="0"/>
+          </a:p>
+        </p:txBody>
+      </p:sp>
+      <p:sp>
+        <p:nvSpPr>
+          <p:cNvPr id="14" name="Text 12"/>
+          <p:cNvSpPr/>
+          <p:nvPr/>
+        </p:nvSpPr>
+        <p:spPr>
+          <a:xfrm>
+            <a:off x="3063240" y="2971800"/>
+            <a:ext cx="1737360" cy="2103120"/>
+          </a:xfrm>
+          <a:prstGeom prst="rect">
+            <a:avLst/>
+          </a:prstGeom>
+          <a:noFill/>
+          <a:ln/>
+        </p:spPr>
+        <p:txBody>
+          <a:bodyPr wrap="square" rtlCol="0" anchor="ctr"/>
+          <a:lstStyle/>
+          <a:p>
+            <a:pPr indent="0" marL="0">
+              <a:buNone/>
+            </a:pPr>
+            <a:r>
+              <a:rPr lang="en-US" sz="950" dirty="0">
                 <a:solidFill>
                   <a:srgbClr val="CBD5E1"/>
                 </a:solidFill>
@@ -7806,22 +8237,22 @@
                 <a:ea typeface="Arial" pitchFamily="34" charset="-122"/>
                 <a:cs typeface="Arial" pitchFamily="34" charset="-120"/>
               </a:rPr>
-              <a:t>Instant visual extraction of complex medical documents, handwritten addendums, and folded summaries in 1.2s.</a:t>
-            </a:r>
-            <a:endParaRPr lang="en-US" sz="1000" dirty="0"/>
-          </a:p>
-        </p:txBody>
-      </p:sp>
-      <p:sp>
-        <p:nvSpPr>
-          <p:cNvPr id="11" name="Shape 9"/>
-          <p:cNvSpPr/>
-          <p:nvPr/>
-        </p:nvSpPr>
-        <p:spPr>
-          <a:xfrm>
-            <a:off x="6217920" y="1920240"/>
-            <a:ext cx="5212080" cy="1737360"/>
+              <a:t>1.2s extraction of doctor handwriting, crumpled summaries &amp; multi-column tables directly.</a:t>
+            </a:r>
+            <a:endParaRPr lang="en-US" sz="950" dirty="0"/>
+          </a:p>
+        </p:txBody>
+      </p:sp>
+      <p:sp>
+        <p:nvSpPr>
+          <p:cNvPr id="15" name="Shape 13"/>
+          <p:cNvSpPr/>
+          <p:nvPr/>
+        </p:nvSpPr>
+        <p:spPr>
+          <a:xfrm>
+            <a:off x="5120640" y="1920240"/>
+            <a:ext cx="2011680" cy="3474720"/>
           </a:xfrm>
           <a:prstGeom prst="roundRect">
             <a:avLst/>
@@ -7829,7 +8260,7 @@
           <a:solidFill>
             <a:srgbClr val="0F172A"/>
           </a:solidFill>
-          <a:ln w="12700">
+          <a:ln w="19050">
             <a:solidFill>
               <a:srgbClr val="06B6D4"/>
             </a:solidFill>
@@ -7839,30 +8270,30 @@
       </p:sp>
       <p:sp>
         <p:nvSpPr>
-          <p:cNvPr id="12" name="Text 10"/>
-          <p:cNvSpPr/>
-          <p:nvPr/>
-        </p:nvSpPr>
-        <p:spPr>
-          <a:xfrm>
-            <a:off x="6492240" y="2103120"/>
-            <a:ext cx="4663440" cy="320040"/>
-          </a:xfrm>
-          <a:prstGeom prst="rect">
-            <a:avLst/>
-          </a:prstGeom>
-          <a:noFill/>
-          <a:ln/>
-        </p:spPr>
-        <p:txBody>
-          <a:bodyPr wrap="square" rtlCol="0" anchor="ctr"/>
-          <a:lstStyle/>
-          <a:p>
-            <a:pPr indent="0" marL="0">
-              <a:buNone/>
-            </a:pPr>
-            <a:r>
-              <a:rPr lang="en-US" sz="1400" b="1" dirty="0">
+          <p:cNvPr id="16" name="Text 14"/>
+          <p:cNvSpPr/>
+          <p:nvPr/>
+        </p:nvSpPr>
+        <p:spPr>
+          <a:xfrm>
+            <a:off x="5257800" y="2103120"/>
+            <a:ext cx="1737360" cy="411480"/>
+          </a:xfrm>
+          <a:prstGeom prst="rect">
+            <a:avLst/>
+          </a:prstGeom>
+          <a:noFill/>
+          <a:ln/>
+        </p:spPr>
+        <p:txBody>
+          <a:bodyPr wrap="square" rtlCol="0" anchor="ctr"/>
+          <a:lstStyle/>
+          <a:p>
+            <a:pPr indent="0" marL="0">
+              <a:buNone/>
+            </a:pPr>
+            <a:r>
+              <a:rPr lang="en-US" sz="1200" b="1" dirty="0">
                 <a:solidFill>
                   <a:srgbClr val="06B6D4"/>
                 </a:solidFill>
@@ -7870,38 +8301,38 @@
                 <a:ea typeface="Arial" pitchFamily="34" charset="-122"/>
                 <a:cs typeface="Arial" pitchFamily="34" charset="-120"/>
               </a:rPr>
-              <a:t>Google Cloud TTS (Neural2)</a:t>
-            </a:r>
-            <a:endParaRPr lang="en-US" sz="1400" dirty="0"/>
-          </a:p>
-        </p:txBody>
-      </p:sp>
-      <p:sp>
-        <p:nvSpPr>
-          <p:cNvPr id="13" name="Text 11"/>
-          <p:cNvSpPr/>
-          <p:nvPr/>
-        </p:nvSpPr>
-        <p:spPr>
-          <a:xfrm>
-            <a:off x="6492240" y="2423160"/>
-            <a:ext cx="4663440" cy="274320"/>
-          </a:xfrm>
-          <a:prstGeom prst="rect">
-            <a:avLst/>
-          </a:prstGeom>
-          <a:noFill/>
-          <a:ln/>
-        </p:spPr>
-        <p:txBody>
-          <a:bodyPr wrap="square" rtlCol="0" anchor="ctr"/>
-          <a:lstStyle/>
-          <a:p>
-            <a:pPr indent="0" marL="0">
-              <a:buNone/>
-            </a:pPr>
-            <a:r>
-              <a:rPr lang="en-US" sz="900" b="1" dirty="0">
+              <a:t>Cloud TTS Neural2</a:t>
+            </a:r>
+            <a:endParaRPr lang="en-US" sz="1200" dirty="0"/>
+          </a:p>
+        </p:txBody>
+      </p:sp>
+      <p:sp>
+        <p:nvSpPr>
+          <p:cNvPr id="17" name="Text 15"/>
+          <p:cNvSpPr/>
+          <p:nvPr/>
+        </p:nvSpPr>
+        <p:spPr>
+          <a:xfrm>
+            <a:off x="5257800" y="2560320"/>
+            <a:ext cx="1737360" cy="320040"/>
+          </a:xfrm>
+          <a:prstGeom prst="rect">
+            <a:avLst/>
+          </a:prstGeom>
+          <a:noFill/>
+          <a:ln/>
+        </p:spPr>
+        <p:txBody>
+          <a:bodyPr wrap="square" rtlCol="0" anchor="ctr"/>
+          <a:lstStyle/>
+          <a:p>
+            <a:pPr indent="0" marL="0">
+              <a:buNone/>
+            </a:pPr>
+            <a:r>
+              <a:rPr lang="en-US" sz="800" b="1" dirty="0">
                 <a:solidFill>
                   <a:srgbClr val="94A3B8"/>
                 </a:solidFill>
@@ -7909,38 +8340,38 @@
                 <a:ea typeface="Arial" pitchFamily="34" charset="-122"/>
                 <a:cs typeface="Arial" pitchFamily="34" charset="-120"/>
               </a:rPr>
-              <a:t>REGIONAL AUDIO VOICE SYNTHESIS</a:t>
-            </a:r>
-            <a:endParaRPr lang="en-US" sz="900" dirty="0"/>
-          </a:p>
-        </p:txBody>
-      </p:sp>
-      <p:sp>
-        <p:nvSpPr>
-          <p:cNvPr id="14" name="Text 12"/>
-          <p:cNvSpPr/>
-          <p:nvPr/>
-        </p:nvSpPr>
-        <p:spPr>
-          <a:xfrm>
-            <a:off x="6492240" y="2743200"/>
-            <a:ext cx="4663440" cy="777240"/>
-          </a:xfrm>
-          <a:prstGeom prst="rect">
-            <a:avLst/>
-          </a:prstGeom>
-          <a:noFill/>
-          <a:ln/>
-        </p:spPr>
-        <p:txBody>
-          <a:bodyPr wrap="square" rtlCol="0" anchor="ctr"/>
-          <a:lstStyle/>
-          <a:p>
-            <a:pPr indent="0" marL="0">
-              <a:buNone/>
-            </a:pPr>
-            <a:r>
-              <a:rPr lang="en-US" sz="1000" dirty="0">
+              <a:t>REGIONAL SPOKEN AUDIO</a:t>
+            </a:r>
+            <a:endParaRPr lang="en-US" sz="800" dirty="0"/>
+          </a:p>
+        </p:txBody>
+      </p:sp>
+      <p:sp>
+        <p:nvSpPr>
+          <p:cNvPr id="18" name="Text 16"/>
+          <p:cNvSpPr/>
+          <p:nvPr/>
+        </p:nvSpPr>
+        <p:spPr>
+          <a:xfrm>
+            <a:off x="5257800" y="2971800"/>
+            <a:ext cx="1737360" cy="2103120"/>
+          </a:xfrm>
+          <a:prstGeom prst="rect">
+            <a:avLst/>
+          </a:prstGeom>
+          <a:noFill/>
+          <a:ln/>
+        </p:spPr>
+        <p:txBody>
+          <a:bodyPr wrap="square" rtlCol="0" anchor="ctr"/>
+          <a:lstStyle/>
+          <a:p>
+            <a:pPr indent="0" marL="0">
+              <a:buNone/>
+            </a:pPr>
+            <a:r>
+              <a:rPr lang="en-US" sz="950" dirty="0">
                 <a:solidFill>
                   <a:srgbClr val="CBD5E1"/>
                 </a:solidFill>
@@ -7948,22 +8379,22 @@
                 <a:ea typeface="Arial" pitchFamily="34" charset="-122"/>
                 <a:cs typeface="Arial" pitchFamily="34" charset="-120"/>
               </a:rPr>
-              <a:t>High-fidelity Hindi &amp; Indian English voice generation powering "Awaaz Parchi" for non-literate family caregivers.</a:t>
-            </a:r>
-            <a:endParaRPr lang="en-US" sz="1000" dirty="0"/>
-          </a:p>
-        </p:txBody>
-      </p:sp>
-      <p:sp>
-        <p:nvSpPr>
-          <p:cNvPr id="15" name="Shape 13"/>
-          <p:cNvSpPr/>
-          <p:nvPr/>
-        </p:nvSpPr>
-        <p:spPr>
-          <a:xfrm>
-            <a:off x="731520" y="3840480"/>
-            <a:ext cx="5212080" cy="1737360"/>
+              <a:t>High-fidelity natural Hindi voice synthesis delivering spoken care instructions for elders.</a:t>
+            </a:r>
+            <a:endParaRPr lang="en-US" sz="950" dirty="0"/>
+          </a:p>
+        </p:txBody>
+      </p:sp>
+      <p:sp>
+        <p:nvSpPr>
+          <p:cNvPr id="19" name="Shape 17"/>
+          <p:cNvSpPr/>
+          <p:nvPr/>
+        </p:nvSpPr>
+        <p:spPr>
+          <a:xfrm>
+            <a:off x="7315200" y="1920240"/>
+            <a:ext cx="2011680" cy="3474720"/>
           </a:xfrm>
           <a:prstGeom prst="roundRect">
             <a:avLst/>
@@ -7971,7 +8402,7 @@
           <a:solidFill>
             <a:srgbClr val="0F172A"/>
           </a:solidFill>
-          <a:ln w="12700">
+          <a:ln w="19050">
             <a:solidFill>
               <a:srgbClr val="F59E0B"/>
             </a:solidFill>
@@ -7981,30 +8412,30 @@
       </p:sp>
       <p:sp>
         <p:nvSpPr>
-          <p:cNvPr id="16" name="Text 14"/>
-          <p:cNvSpPr/>
-          <p:nvPr/>
-        </p:nvSpPr>
-        <p:spPr>
-          <a:xfrm>
-            <a:off x="1005840" y="4023360"/>
-            <a:ext cx="4663440" cy="320040"/>
-          </a:xfrm>
-          <a:prstGeom prst="rect">
-            <a:avLst/>
-          </a:prstGeom>
-          <a:noFill/>
-          <a:ln/>
-        </p:spPr>
-        <p:txBody>
-          <a:bodyPr wrap="square" rtlCol="0" anchor="ctr"/>
-          <a:lstStyle/>
-          <a:p>
-            <a:pPr indent="0" marL="0">
-              <a:buNone/>
-            </a:pPr>
-            <a:r>
-              <a:rPr lang="en-US" sz="1400" b="1" dirty="0">
+          <p:cNvPr id="20" name="Text 18"/>
+          <p:cNvSpPr/>
+          <p:nvPr/>
+        </p:nvSpPr>
+        <p:spPr>
+          <a:xfrm>
+            <a:off x="7452360" y="2103120"/>
+            <a:ext cx="1737360" cy="411480"/>
+          </a:xfrm>
+          <a:prstGeom prst="rect">
+            <a:avLst/>
+          </a:prstGeom>
+          <a:noFill/>
+          <a:ln/>
+        </p:spPr>
+        <p:txBody>
+          <a:bodyPr wrap="square" rtlCol="0" anchor="ctr"/>
+          <a:lstStyle/>
+          <a:p>
+            <a:pPr indent="0" marL="0">
+              <a:buNone/>
+            </a:pPr>
+            <a:r>
+              <a:rPr lang="en-US" sz="1200" b="1" dirty="0">
                 <a:solidFill>
                   <a:srgbClr val="F59E0B"/>
                 </a:solidFill>
@@ -8012,38 +8443,38 @@
                 <a:ea typeface="Arial" pitchFamily="34" charset="-122"/>
                 <a:cs typeface="Arial" pitchFamily="34" charset="-120"/>
               </a:rPr>
-              <a:t>Google Calendar (RFC 5545)</a:t>
-            </a:r>
-            <a:endParaRPr lang="en-US" sz="1400" dirty="0"/>
-          </a:p>
-        </p:txBody>
-      </p:sp>
-      <p:sp>
-        <p:nvSpPr>
-          <p:cNvPr id="17" name="Text 15"/>
-          <p:cNvSpPr/>
-          <p:nvPr/>
-        </p:nvSpPr>
-        <p:spPr>
-          <a:xfrm>
-            <a:off x="1005840" y="4343400"/>
-            <a:ext cx="4663440" cy="274320"/>
-          </a:xfrm>
-          <a:prstGeom prst="rect">
-            <a:avLst/>
-          </a:prstGeom>
-          <a:noFill/>
-          <a:ln/>
-        </p:spPr>
-        <p:txBody>
-          <a:bodyPr wrap="square" rtlCol="0" anchor="ctr"/>
-          <a:lstStyle/>
-          <a:p>
-            <a:pPr indent="0" marL="0">
-              <a:buNone/>
-            </a:pPr>
-            <a:r>
-              <a:rPr lang="en-US" sz="900" b="1" dirty="0">
+              <a:t>Google Calendar</a:t>
+            </a:r>
+            <a:endParaRPr lang="en-US" sz="1200" dirty="0"/>
+          </a:p>
+        </p:txBody>
+      </p:sp>
+      <p:sp>
+        <p:nvSpPr>
+          <p:cNvPr id="21" name="Text 19"/>
+          <p:cNvSpPr/>
+          <p:nvPr/>
+        </p:nvSpPr>
+        <p:spPr>
+          <a:xfrm>
+            <a:off x="7452360" y="2560320"/>
+            <a:ext cx="1737360" cy="320040"/>
+          </a:xfrm>
+          <a:prstGeom prst="rect">
+            <a:avLst/>
+          </a:prstGeom>
+          <a:noFill/>
+          <a:ln/>
+        </p:spPr>
+        <p:txBody>
+          <a:bodyPr wrap="square" rtlCol="0" anchor="ctr"/>
+          <a:lstStyle/>
+          <a:p>
+            <a:pPr indent="0" marL="0">
+              <a:buNone/>
+            </a:pPr>
+            <a:r>
+              <a:rPr lang="en-US" sz="800" b="1" dirty="0">
                 <a:solidFill>
                   <a:srgbClr val="94A3B8"/>
                 </a:solidFill>
@@ -8051,38 +8482,38 @@
                 <a:ea typeface="Arial" pitchFamily="34" charset="-122"/>
                 <a:cs typeface="Arial" pitchFamily="34" charset="-120"/>
               </a:rPr>
-              <a:t>AUTOMATED MEDICATION ALARMS</a:t>
-            </a:r>
-            <a:endParaRPr lang="en-US" sz="900" dirty="0"/>
-          </a:p>
-        </p:txBody>
-      </p:sp>
-      <p:sp>
-        <p:nvSpPr>
-          <p:cNvPr id="18" name="Text 16"/>
-          <p:cNvSpPr/>
-          <p:nvPr/>
-        </p:nvSpPr>
-        <p:spPr>
-          <a:xfrm>
-            <a:off x="1005840" y="4663440"/>
-            <a:ext cx="4663440" cy="777240"/>
-          </a:xfrm>
-          <a:prstGeom prst="rect">
-            <a:avLst/>
-          </a:prstGeom>
-          <a:noFill/>
-          <a:ln/>
-        </p:spPr>
-        <p:txBody>
-          <a:bodyPr wrap="square" rtlCol="0" anchor="ctr"/>
-          <a:lstStyle/>
-          <a:p>
-            <a:pPr indent="0" marL="0">
-              <a:buNone/>
-            </a:pPr>
-            <a:r>
-              <a:rPr lang="en-US" sz="1000" dirty="0">
+              <a:t>MEDICATION ALARMS ENGINE</a:t>
+            </a:r>
+            <a:endParaRPr lang="en-US" sz="800" dirty="0"/>
+          </a:p>
+        </p:txBody>
+      </p:sp>
+      <p:sp>
+        <p:nvSpPr>
+          <p:cNvPr id="22" name="Text 20"/>
+          <p:cNvSpPr/>
+          <p:nvPr/>
+        </p:nvSpPr>
+        <p:spPr>
+          <a:xfrm>
+            <a:off x="7452360" y="2971800"/>
+            <a:ext cx="1737360" cy="2103120"/>
+          </a:xfrm>
+          <a:prstGeom prst="rect">
+            <a:avLst/>
+          </a:prstGeom>
+          <a:noFill/>
+          <a:ln/>
+        </p:spPr>
+        <p:txBody>
+          <a:bodyPr wrap="square" rtlCol="0" anchor="ctr"/>
+          <a:lstStyle/>
+          <a:p>
+            <a:pPr indent="0" marL="0">
+              <a:buNone/>
+            </a:pPr>
+            <a:r>
+              <a:rPr lang="en-US" sz="950" dirty="0">
                 <a:solidFill>
                   <a:srgbClr val="CBD5E1"/>
                 </a:solidFill>
@@ -8090,22 +8521,22 @@
                 <a:ea typeface="Arial" pitchFamily="34" charset="-122"/>
                 <a:cs typeface="Arial" pitchFamily="34" charset="-120"/>
               </a:rPr>
-              <a:t>Generates standard ICS calendar alarms with 1-click sync to Google Calendar on patient smartphones.</a:t>
-            </a:r>
-            <a:endParaRPr lang="en-US" sz="1000" dirty="0"/>
-          </a:p>
-        </p:txBody>
-      </p:sp>
-      <p:sp>
-        <p:nvSpPr>
-          <p:cNvPr id="19" name="Shape 17"/>
-          <p:cNvSpPr/>
-          <p:nvPr/>
-        </p:nvSpPr>
-        <p:spPr>
-          <a:xfrm>
-            <a:off x="6217920" y="3840480"/>
-            <a:ext cx="5212080" cy="1737360"/>
+              <a:t>RFC 5545 schedule sync: 1-click adds all pill alarms and review appointments to phones.</a:t>
+            </a:r>
+            <a:endParaRPr lang="en-US" sz="950" dirty="0"/>
+          </a:p>
+        </p:txBody>
+      </p:sp>
+      <p:sp>
+        <p:nvSpPr>
+          <p:cNvPr id="23" name="Shape 21"/>
+          <p:cNvSpPr/>
+          <p:nvPr/>
+        </p:nvSpPr>
+        <p:spPr>
+          <a:xfrm>
+            <a:off x="9509760" y="1920240"/>
+            <a:ext cx="2011680" cy="3474720"/>
           </a:xfrm>
           <a:prstGeom prst="roundRect">
             <a:avLst/>
@@ -8113,7 +8544,7 @@
           <a:solidFill>
             <a:srgbClr val="0F172A"/>
           </a:solidFill>
-          <a:ln w="12700">
+          <a:ln w="19050">
             <a:solidFill>
               <a:srgbClr val="10B981"/>
             </a:solidFill>
@@ -8123,30 +8554,30 @@
       </p:sp>
       <p:sp>
         <p:nvSpPr>
-          <p:cNvPr id="20" name="Text 18"/>
-          <p:cNvSpPr/>
-          <p:nvPr/>
-        </p:nvSpPr>
-        <p:spPr>
-          <a:xfrm>
-            <a:off x="6492240" y="4023360"/>
-            <a:ext cx="4663440" cy="320040"/>
-          </a:xfrm>
-          <a:prstGeom prst="rect">
-            <a:avLst/>
-          </a:prstGeom>
-          <a:noFill/>
-          <a:ln/>
-        </p:spPr>
-        <p:txBody>
-          <a:bodyPr wrap="square" rtlCol="0" anchor="ctr"/>
-          <a:lstStyle/>
-          <a:p>
-            <a:pPr indent="0" marL="0">
-              <a:buNone/>
-            </a:pPr>
-            <a:r>
-              <a:rPr lang="en-US" sz="1400" b="1" dirty="0">
+          <p:cNvPr id="24" name="Text 22"/>
+          <p:cNvSpPr/>
+          <p:nvPr/>
+        </p:nvSpPr>
+        <p:spPr>
+          <a:xfrm>
+            <a:off x="9646920" y="2103120"/>
+            <a:ext cx="1737360" cy="411480"/>
+          </a:xfrm>
+          <a:prstGeom prst="rect">
+            <a:avLst/>
+          </a:prstGeom>
+          <a:noFill/>
+          <a:ln/>
+        </p:spPr>
+        <p:txBody>
+          <a:bodyPr wrap="square" rtlCol="0" anchor="ctr"/>
+          <a:lstStyle/>
+          <a:p>
+            <a:pPr indent="0" marL="0">
+              <a:buNone/>
+            </a:pPr>
+            <a:r>
+              <a:rPr lang="en-US" sz="1200" b="1" dirty="0">
                 <a:solidFill>
                   <a:srgbClr val="10B981"/>
                 </a:solidFill>
@@ -8154,38 +8585,38 @@
                 <a:ea typeface="Arial" pitchFamily="34" charset="-122"/>
                 <a:cs typeface="Arial" pitchFamily="34" charset="-120"/>
               </a:rPr>
-              <a:t>Google Maps &amp; Jan Aushadhi</a:t>
-            </a:r>
-            <a:endParaRPr lang="en-US" sz="1400" dirty="0"/>
-          </a:p>
-        </p:txBody>
-      </p:sp>
-      <p:sp>
-        <p:nvSpPr>
-          <p:cNvPr id="21" name="Text 19"/>
-          <p:cNvSpPr/>
-          <p:nvPr/>
-        </p:nvSpPr>
-        <p:spPr>
-          <a:xfrm>
-            <a:off x="6492240" y="4343400"/>
-            <a:ext cx="4663440" cy="274320"/>
-          </a:xfrm>
-          <a:prstGeom prst="rect">
-            <a:avLst/>
-          </a:prstGeom>
-          <a:noFill/>
-          <a:ln/>
-        </p:spPr>
-        <p:txBody>
-          <a:bodyPr wrap="square" rtlCol="0" anchor="ctr"/>
-          <a:lstStyle/>
-          <a:p>
-            <a:pPr indent="0" marL="0">
-              <a:buNone/>
-            </a:pPr>
-            <a:r>
-              <a:rPr lang="en-US" sz="900" b="1" dirty="0">
+              <a:t>Google Maps API</a:t>
+            </a:r>
+            <a:endParaRPr lang="en-US" sz="1200" dirty="0"/>
+          </a:p>
+        </p:txBody>
+      </p:sp>
+      <p:sp>
+        <p:nvSpPr>
+          <p:cNvPr id="25" name="Text 23"/>
+          <p:cNvSpPr/>
+          <p:nvPr/>
+        </p:nvSpPr>
+        <p:spPr>
+          <a:xfrm>
+            <a:off x="9646920" y="2560320"/>
+            <a:ext cx="1737360" cy="320040"/>
+          </a:xfrm>
+          <a:prstGeom prst="rect">
+            <a:avLst/>
+          </a:prstGeom>
+          <a:noFill/>
+          <a:ln/>
+        </p:spPr>
+        <p:txBody>
+          <a:bodyPr wrap="square" rtlCol="0" anchor="ctr"/>
+          <a:lstStyle/>
+          <a:p>
+            <a:pPr indent="0" marL="0">
+              <a:buNone/>
+            </a:pPr>
+            <a:r>
+              <a:rPr lang="en-US" sz="800" b="1" dirty="0">
                 <a:solidFill>
                   <a:srgbClr val="94A3B8"/>
                 </a:solidFill>
@@ -8193,38 +8624,38 @@
                 <a:ea typeface="Arial" pitchFamily="34" charset="-122"/>
                 <a:cs typeface="Arial" pitchFamily="34" charset="-120"/>
               </a:rPr>
-              <a:t>AFFORDABLE PHARMACY NAVIGATION</a:t>
-            </a:r>
-            <a:endParaRPr lang="en-US" sz="900" dirty="0"/>
-          </a:p>
-        </p:txBody>
-      </p:sp>
-      <p:sp>
-        <p:nvSpPr>
-          <p:cNvPr id="22" name="Text 20"/>
-          <p:cNvSpPr/>
-          <p:nvPr/>
-        </p:nvSpPr>
-        <p:spPr>
-          <a:xfrm>
-            <a:off x="6492240" y="4663440"/>
-            <a:ext cx="4663440" cy="777240"/>
-          </a:xfrm>
-          <a:prstGeom prst="rect">
-            <a:avLst/>
-          </a:prstGeom>
-          <a:noFill/>
-          <a:ln/>
-        </p:spPr>
-        <p:txBody>
-          <a:bodyPr wrap="square" rtlCol="0" anchor="ctr"/>
-          <a:lstStyle/>
-          <a:p>
-            <a:pPr indent="0" marL="0">
-              <a:buNone/>
-            </a:pPr>
-            <a:r>
-              <a:rPr lang="en-US" sz="1000" dirty="0">
+              <a:t>24/7 JAN AUSHADHI LOCATOR</a:t>
+            </a:r>
+            <a:endParaRPr lang="en-US" sz="800" dirty="0"/>
+          </a:p>
+        </p:txBody>
+      </p:sp>
+      <p:sp>
+        <p:nvSpPr>
+          <p:cNvPr id="26" name="Text 24"/>
+          <p:cNvSpPr/>
+          <p:nvPr/>
+        </p:nvSpPr>
+        <p:spPr>
+          <a:xfrm>
+            <a:off x="9646920" y="2971800"/>
+            <a:ext cx="1737360" cy="2103120"/>
+          </a:xfrm>
+          <a:prstGeom prst="rect">
+            <a:avLst/>
+          </a:prstGeom>
+          <a:noFill/>
+          <a:ln/>
+        </p:spPr>
+        <p:txBody>
+          <a:bodyPr wrap="square" rtlCol="0" anchor="ctr"/>
+          <a:lstStyle/>
+          <a:p>
+            <a:pPr indent="0" marL="0">
+              <a:buNone/>
+            </a:pPr>
+            <a:r>
+              <a:rPr lang="en-US" sz="950" dirty="0">
                 <a:solidFill>
                   <a:srgbClr val="CBD5E1"/>
                 </a:solidFill>
@@ -8232,22 +8663,22 @@
                 <a:ea typeface="Arial" pitchFamily="34" charset="-122"/>
                 <a:cs typeface="Arial" pitchFamily="34" charset="-120"/>
               </a:rPr>
-              <a:t>Geo-locates 24/7 emergency pharmacies &amp; PMBJP Jan Aushadhi Kendras within 3km, cutting medicine costs up to 85%.</a:t>
-            </a:r>
-            <a:endParaRPr lang="en-US" sz="1000" dirty="0"/>
-          </a:p>
-        </p:txBody>
-      </p:sp>
-      <p:sp>
-        <p:nvSpPr>
-          <p:cNvPr id="23" name="Shape 21"/>
-          <p:cNvSpPr/>
-          <p:nvPr/>
-        </p:nvSpPr>
-        <p:spPr>
-          <a:xfrm>
-            <a:off x="731520" y="5715000"/>
-            <a:ext cx="10698480" cy="411480"/>
+              <a:t>Pins nearest verified generic pharmacies within 3km, cutting family costs by up to 85%.</a:t>
+            </a:r>
+            <a:endParaRPr lang="en-US" sz="950" dirty="0"/>
+          </a:p>
+        </p:txBody>
+      </p:sp>
+      <p:sp>
+        <p:nvSpPr>
+          <p:cNvPr id="27" name="Shape 25"/>
+          <p:cNvSpPr/>
+          <p:nvPr/>
+        </p:nvSpPr>
+        <p:spPr>
+          <a:xfrm>
+            <a:off x="731520" y="5577840"/>
+            <a:ext cx="10698480" cy="548640"/>
           </a:xfrm>
           <a:prstGeom prst="roundRect">
             <a:avLst/>
@@ -8265,14 +8696,14 @@
       </p:sp>
       <p:sp>
         <p:nvSpPr>
-          <p:cNvPr id="24" name="Text 22"/>
-          <p:cNvSpPr/>
-          <p:nvPr/>
-        </p:nvSpPr>
-        <p:spPr>
-          <a:xfrm>
-            <a:off x="914400" y="5806440"/>
-            <a:ext cx="10332720" cy="228600"/>
+          <p:cNvPr id="28" name="Text 26"/>
+          <p:cNvSpPr/>
+          <p:nvPr/>
+        </p:nvSpPr>
+        <p:spPr>
+          <a:xfrm>
+            <a:off x="914400" y="5715000"/>
+            <a:ext cx="10332720" cy="274320"/>
           </a:xfrm>
           <a:prstGeom prst="rect">
             <a:avLst/>
@@ -8288,7 +8719,7 @@
               <a:buNone/>
             </a:pPr>
             <a:r>
-              <a:rPr lang="en-US" sz="900" b="1" dirty="0">
+              <a:rPr lang="en-US" sz="950" b="1" dirty="0">
                 <a:solidFill>
                   <a:srgbClr val="14B8A6"/>
                 </a:solidFill>
@@ -8296,9 +8727,9 @@
                 <a:ea typeface="Arial" pitchFamily="34" charset="-122"/>
                 <a:cs typeface="Arial" pitchFamily="34" charset="-120"/>
               </a:rPr>
-              <a:t>ABDM COMPLIANCE: Ready for National Ayushman Bharat Digital Mission • FHIR R4 Discharge Summary Export</a:t>
-            </a:r>
-            <a:endParaRPr lang="en-US" sz="900" dirty="0"/>
+              <a:t>ALL 5 GOOGLE RAILS FULLY INTEGRATED IN GHARCARE • GCP PROJECT: gharcare-aayu-2026</a:t>
+            </a:r>
+            <a:endParaRPr lang="en-US" sz="950" dirty="0"/>
           </a:p>
         </p:txBody>
       </p:sp>

</xml_diff>